<commit_message>
Update We’ll Cross That Bridge When We Get There.pptx
</commit_message>
<xml_diff>
--- a/We’ll Cross That Bridge When We Get There.pptx
+++ b/We’ll Cross That Bridge When We Get There.pptx
@@ -5,17 +5,22 @@
     <p:sldMasterId id="2147483648" r:id="rId1"/>
   </p:sldMasterIdLst>
   <p:notesMasterIdLst>
-    <p:notesMasterId r:id="rId7"/>
+    <p:notesMasterId r:id="rId12"/>
   </p:notesMasterIdLst>
   <p:handoutMasterIdLst>
-    <p:handoutMasterId r:id="rId8"/>
+    <p:handoutMasterId r:id="rId13"/>
   </p:handoutMasterIdLst>
   <p:sldIdLst>
     <p:sldId id="284" r:id="rId2"/>
-    <p:sldId id="286" r:id="rId3"/>
-    <p:sldId id="287" r:id="rId4"/>
-    <p:sldId id="288" r:id="rId5"/>
-    <p:sldId id="289" r:id="rId6"/>
+    <p:sldId id="291" r:id="rId3"/>
+    <p:sldId id="293" r:id="rId4"/>
+    <p:sldId id="295" r:id="rId5"/>
+    <p:sldId id="294" r:id="rId6"/>
+    <p:sldId id="292" r:id="rId7"/>
+    <p:sldId id="286" r:id="rId8"/>
+    <p:sldId id="287" r:id="rId9"/>
+    <p:sldId id="288" r:id="rId10"/>
+    <p:sldId id="289" r:id="rId11"/>
   </p:sldIdLst>
   <p:sldSz cx="12192000" cy="6858000"/>
   <p:notesSz cx="6858000" cy="9144000"/>
@@ -120,6 +125,11 @@
         <p14:section name="Instructions" id="{5EC75C8C-8851-4EC1-83E3-ADCB0283ABBC}">
           <p14:sldIdLst>
             <p14:sldId id="284"/>
+            <p14:sldId id="291"/>
+            <p14:sldId id="293"/>
+            <p14:sldId id="295"/>
+            <p14:sldId id="294"/>
+            <p14:sldId id="292"/>
             <p14:sldId id="286"/>
             <p14:sldId id="287"/>
             <p14:sldId id="288"/>
@@ -237,7 +247,7 @@
           <a:p>
             <a:fld id="{412A36AD-C140-47B5-A0AA-2808AF1C1C9D}" type="datetimeFigureOut">
               <a:rPr lang="en-AU" smtClean="0"/>
-              <a:t>22/01/2025</a:t>
+              <a:t>30/03/2025</a:t>
             </a:fld>
             <a:endParaRPr lang="en-AU"/>
           </a:p>
@@ -402,7 +412,7 @@
           <a:p>
             <a:fld id="{2763829E-EB69-4A98-9D54-8D6822520B27}" type="datetimeFigureOut">
               <a:rPr lang="en-AU" smtClean="0"/>
-              <a:t>22/01/2025</a:t>
+              <a:t>30/03/2025</a:t>
             </a:fld>
             <a:endParaRPr lang="en-AU"/>
           </a:p>
@@ -33194,7 +33204,7 @@
           <a:p>
             <a:r>
               <a:rPr lang="en-AU" dirty="0"/>
-              <a:t>Ancestral Character Reconstruction with Monte Carlo Diffusion Bridge Sampling</a:t>
+              <a:t>Novel Approaches to Ancestral Trait Reconstruction (And an Appropriately Unhinged Recap of the Field)</a:t>
             </a:r>
           </a:p>
         </p:txBody>
@@ -33203,6 +33213,495 @@
     <p:extLst>
       <p:ext uri="{BB962C8B-B14F-4D97-AF65-F5344CB8AC3E}">
         <p14:creationId xmlns:p14="http://schemas.microsoft.com/office/powerpoint/2010/main" val="2934808045"/>
+      </p:ext>
+    </p:extLst>
+  </p:cSld>
+  <p:clrMapOvr>
+    <a:masterClrMapping/>
+  </p:clrMapOvr>
+  <mc:AlternateContent xmlns:mc="http://schemas.openxmlformats.org/markup-compatibility/2006" xmlns:p14="http://schemas.microsoft.com/office/powerpoint/2010/main">
+    <mc:Choice Requires="p14">
+      <p:transition spd="med" p14:dur="700">
+        <p:fade/>
+      </p:transition>
+    </mc:Choice>
+    <mc:Fallback xmlns="">
+      <p:transition spd="med">
+        <p:fade/>
+      </p:transition>
+    </mc:Fallback>
+  </mc:AlternateContent>
+</p:sld>
+</file>
+
+<file path=ppt/slides/slide10.xml><?xml version="1.0" encoding="utf-8"?>
+<p:sld xmlns:a="http://schemas.openxmlformats.org/drawingml/2006/main" xmlns:r="http://schemas.openxmlformats.org/officeDocument/2006/relationships" xmlns:p="http://schemas.openxmlformats.org/presentationml/2006/main">
+  <p:cSld>
+    <p:spTree>
+      <p:nvGrpSpPr>
+        <p:cNvPr id="1" name=""/>
+        <p:cNvGrpSpPr/>
+        <p:nvPr/>
+      </p:nvGrpSpPr>
+      <p:grpSpPr>
+        <a:xfrm>
+          <a:off x="0" y="0"/>
+          <a:ext cx="0" cy="0"/>
+          <a:chOff x="0" y="0"/>
+          <a:chExt cx="0" cy="0"/>
+        </a:xfrm>
+      </p:grpSpPr>
+      <p:sp>
+        <p:nvSpPr>
+          <p:cNvPr id="10" name="Footer Placeholder 1">
+            <a:extLst>
+              <a:ext uri="{FF2B5EF4-FFF2-40B4-BE49-F238E27FC236}">
+                <a16:creationId xmlns:a16="http://schemas.microsoft.com/office/drawing/2014/main" id="{212A69FA-ED78-890A-E3D1-2CEDA8374AAE}"/>
+              </a:ext>
+            </a:extLst>
+          </p:cNvPr>
+          <p:cNvSpPr>
+            <a:spLocks noGrp="1"/>
+          </p:cNvSpPr>
+          <p:nvPr>
+            <p:ph type="ftr" sz="quarter" idx="17"/>
+          </p:nvPr>
+        </p:nvSpPr>
+        <p:spPr>
+          <a:xfrm>
+            <a:off x="695326" y="6526800"/>
+            <a:ext cx="3360109" cy="108000"/>
+          </a:xfrm>
+        </p:spPr>
+        <p:txBody>
+          <a:bodyPr/>
+          <a:lstStyle/>
+          <a:p>
+            <a:endParaRPr lang="en-AU"/>
+          </a:p>
+        </p:txBody>
+      </p:sp>
+      <p:sp>
+        <p:nvSpPr>
+          <p:cNvPr id="5" name="Slide Number Placeholder 4">
+            <a:extLst>
+              <a:ext uri="{FF2B5EF4-FFF2-40B4-BE49-F238E27FC236}">
+                <a16:creationId xmlns:a16="http://schemas.microsoft.com/office/drawing/2014/main" id="{42124E07-F817-8BE4-DDEB-9DB8AE101FDC}"/>
+              </a:ext>
+            </a:extLst>
+          </p:cNvPr>
+          <p:cNvSpPr>
+            <a:spLocks noGrp="1"/>
+          </p:cNvSpPr>
+          <p:nvPr>
+            <p:ph type="sldNum" sz="quarter" idx="18"/>
+          </p:nvPr>
+        </p:nvSpPr>
+        <p:spPr>
+          <a:xfrm>
+            <a:off x="11208568" y="6526800"/>
+            <a:ext cx="288032" cy="108000"/>
+          </a:xfrm>
+        </p:spPr>
+        <p:txBody>
+          <a:bodyPr anchor="ctr">
+            <a:normAutofit/>
+          </a:bodyPr>
+          <a:lstStyle/>
+          <a:p>
+            <a:pPr>
+              <a:spcAft>
+                <a:spcPts val="600"/>
+              </a:spcAft>
+            </a:pPr>
+            <a:fld id="{E917DE0E-AFB1-41FD-BC35-27DB61CA125F}" type="slidenum">
+              <a:rPr lang="en-AU" sz="700" smtClean="0"/>
+              <a:pPr>
+                <a:spcAft>
+                  <a:spcPts val="600"/>
+                </a:spcAft>
+              </a:pPr>
+              <a:t>10</a:t>
+            </a:fld>
+            <a:endParaRPr lang="en-AU" sz="700"/>
+          </a:p>
+        </p:txBody>
+      </p:sp>
+      <p:sp>
+        <p:nvSpPr>
+          <p:cNvPr id="12" name="Content Placeholder 3">
+            <a:extLst>
+              <a:ext uri="{FF2B5EF4-FFF2-40B4-BE49-F238E27FC236}">
+                <a16:creationId xmlns:a16="http://schemas.microsoft.com/office/drawing/2014/main" id="{A7E7BA24-E139-8637-75C3-57E193FCEF37}"/>
+              </a:ext>
+            </a:extLst>
+          </p:cNvPr>
+          <p:cNvSpPr>
+            <a:spLocks noGrp="1"/>
+          </p:cNvSpPr>
+          <p:nvPr>
+            <p:ph sz="quarter" idx="10"/>
+          </p:nvPr>
+        </p:nvSpPr>
+        <p:spPr>
+          <a:xfrm>
+            <a:off x="695326" y="2030400"/>
+            <a:ext cx="5040000" cy="3956400"/>
+          </a:xfrm>
+        </p:spPr>
+        <p:txBody>
+          <a:bodyPr/>
+          <a:lstStyle/>
+          <a:p>
+            <a:pPr marL="285750" indent="-285750">
+              <a:buFont typeface="Arial" panose="020B0604020202020204" pitchFamily="34" charset="0"/>
+              <a:buChar char="•"/>
+            </a:pPr>
+            <a:r>
+              <a:rPr lang="en-US" dirty="0"/>
+              <a:t>Diffusion Bridges Allow us to extend our SDE</a:t>
+            </a:r>
+          </a:p>
+          <a:p>
+            <a:pPr marL="285750" indent="-285750">
+              <a:buFont typeface="Arial" panose="020B0604020202020204" pitchFamily="34" charset="0"/>
+              <a:buChar char="•"/>
+            </a:pPr>
+            <a:r>
+              <a:rPr lang="en-US" dirty="0"/>
+              <a:t>A Diffusion Bridge is an SDE where the value (v) at a time T is known</a:t>
+            </a:r>
+          </a:p>
+          <a:p>
+            <a:pPr marL="285750" indent="-285750">
+              <a:buFont typeface="Arial" panose="020B0604020202020204" pitchFamily="34" charset="0"/>
+              <a:buChar char="•"/>
+            </a:pPr>
+            <a:r>
+              <a:rPr lang="en-US" dirty="0"/>
+              <a:t>Given this there are a set number of solutions to the SDE and we can sample from the list of viable solutions</a:t>
+            </a:r>
+          </a:p>
+          <a:p>
+            <a:pPr marL="285750" indent="-285750">
+              <a:buFont typeface="Arial" panose="020B0604020202020204" pitchFamily="34" charset="0"/>
+              <a:buChar char="•"/>
+            </a:pPr>
+            <a:r>
+              <a:rPr lang="en-US" dirty="0"/>
+              <a:t>For our phylogeny: given two known tip values, we can Simulate BM over the branches between them (T) to our known value (v)</a:t>
+            </a:r>
+          </a:p>
+          <a:p>
+            <a:pPr marL="285750" indent="-285750">
+              <a:buFont typeface="Arial" panose="020B0604020202020204" pitchFamily="34" charset="0"/>
+              <a:buChar char="•"/>
+            </a:pPr>
+            <a:r>
+              <a:rPr lang="en-US" dirty="0"/>
+              <a:t>We can continue this process down the tree leading to our first 2 figures</a:t>
+            </a:r>
+          </a:p>
+        </p:txBody>
+      </p:sp>
+      <p:sp>
+        <p:nvSpPr>
+          <p:cNvPr id="14" name="Title 4">
+            <a:extLst>
+              <a:ext uri="{FF2B5EF4-FFF2-40B4-BE49-F238E27FC236}">
+                <a16:creationId xmlns:a16="http://schemas.microsoft.com/office/drawing/2014/main" id="{F9610EC7-F72E-75B1-F091-08A4F9AAD0C0}"/>
+              </a:ext>
+            </a:extLst>
+          </p:cNvPr>
+          <p:cNvSpPr>
+            <a:spLocks noGrp="1"/>
+          </p:cNvSpPr>
+          <p:nvPr>
+            <p:ph type="title"/>
+          </p:nvPr>
+        </p:nvSpPr>
+        <p:spPr>
+          <a:xfrm>
+            <a:off x="695325" y="763200"/>
+            <a:ext cx="9576000" cy="469056"/>
+          </a:xfrm>
+        </p:spPr>
+        <p:txBody>
+          <a:bodyPr/>
+          <a:lstStyle/>
+          <a:p>
+            <a:r>
+              <a:rPr lang="en-US" dirty="0"/>
+              <a:t>Bridging the Gap</a:t>
+            </a:r>
+          </a:p>
+        </p:txBody>
+      </p:sp>
+      <p:sp>
+        <p:nvSpPr>
+          <p:cNvPr id="16" name="Text Placeholder 5">
+            <a:extLst>
+              <a:ext uri="{FF2B5EF4-FFF2-40B4-BE49-F238E27FC236}">
+                <a16:creationId xmlns:a16="http://schemas.microsoft.com/office/drawing/2014/main" id="{6A13694D-99A6-E16A-C1A6-3D6F0CC30E2A}"/>
+              </a:ext>
+            </a:extLst>
+          </p:cNvPr>
+          <p:cNvSpPr>
+            <a:spLocks noGrp="1"/>
+          </p:cNvSpPr>
+          <p:nvPr>
+            <p:ph type="body" sz="quarter" idx="31"/>
+          </p:nvPr>
+        </p:nvSpPr>
+        <p:spPr>
+          <a:xfrm>
+            <a:off x="695325" y="1364400"/>
+            <a:ext cx="9576000" cy="506132"/>
+          </a:xfrm>
+        </p:spPr>
+        <p:txBody>
+          <a:bodyPr/>
+          <a:lstStyle/>
+          <a:p>
+            <a:r>
+              <a:rPr lang="en-US" dirty="0"/>
+              <a:t>Start with the knowns</a:t>
+            </a:r>
+          </a:p>
+        </p:txBody>
+      </p:sp>
+      <p:pic>
+        <p:nvPicPr>
+          <p:cNvPr id="7" name="Content Placeholder 6" descr="A graph of a tree depth&#10;&#10;Description automatically generated">
+            <a:extLst>
+              <a:ext uri="{FF2B5EF4-FFF2-40B4-BE49-F238E27FC236}">
+                <a16:creationId xmlns:a16="http://schemas.microsoft.com/office/drawing/2014/main" id="{6BAA9862-DD37-1704-41F7-81D4E849A9EE}"/>
+              </a:ext>
+            </a:extLst>
+          </p:cNvPr>
+          <p:cNvPicPr>
+            <a:picLocks noGrp="1" noChangeAspect="1"/>
+          </p:cNvPicPr>
+          <p:nvPr>
+            <p:ph sz="quarter" idx="32"/>
+          </p:nvPr>
+        </p:nvPicPr>
+        <p:blipFill>
+          <a:blip r:embed="rId2"/>
+          <a:stretch>
+            <a:fillRect/>
+          </a:stretch>
+        </p:blipFill>
+        <p:spPr>
+          <a:xfrm>
+            <a:off x="6559888" y="854649"/>
+            <a:ext cx="3527253" cy="2351502"/>
+          </a:xfrm>
+        </p:spPr>
+      </p:pic>
+      <p:pic>
+        <p:nvPicPr>
+          <p:cNvPr id="9" name="Picture 8" descr="A graph of a graph&#10;&#10;Description automatically generated">
+            <a:extLst>
+              <a:ext uri="{FF2B5EF4-FFF2-40B4-BE49-F238E27FC236}">
+                <a16:creationId xmlns:a16="http://schemas.microsoft.com/office/drawing/2014/main" id="{DDE90736-3A54-C926-AD3E-A8A55BA03342}"/>
+              </a:ext>
+            </a:extLst>
+          </p:cNvPr>
+          <p:cNvPicPr>
+            <a:picLocks noChangeAspect="1"/>
+          </p:cNvPicPr>
+          <p:nvPr/>
+        </p:nvPicPr>
+        <p:blipFill>
+          <a:blip r:embed="rId3"/>
+          <a:stretch>
+            <a:fillRect/>
+          </a:stretch>
+        </p:blipFill>
+        <p:spPr>
+          <a:xfrm>
+            <a:off x="6670925" y="3268519"/>
+            <a:ext cx="3600400" cy="2400267"/>
+          </a:xfrm>
+          <a:prstGeom prst="rect">
+            <a:avLst/>
+          </a:prstGeom>
+        </p:spPr>
+      </p:pic>
+      <p:sp>
+        <p:nvSpPr>
+          <p:cNvPr id="11" name="TextBox 10">
+            <a:extLst>
+              <a:ext uri="{FF2B5EF4-FFF2-40B4-BE49-F238E27FC236}">
+                <a16:creationId xmlns:a16="http://schemas.microsoft.com/office/drawing/2014/main" id="{D301F6FD-8306-753C-936F-84B4EE7CA791}"/>
+              </a:ext>
+            </a:extLst>
+          </p:cNvPr>
+          <p:cNvSpPr txBox="1"/>
+          <p:nvPr/>
+        </p:nvSpPr>
+        <p:spPr>
+          <a:xfrm>
+            <a:off x="6816080" y="5638016"/>
+            <a:ext cx="3455246" cy="830997"/>
+          </a:xfrm>
+          <a:prstGeom prst="rect">
+            <a:avLst/>
+          </a:prstGeom>
+          <a:noFill/>
+        </p:spPr>
+        <p:txBody>
+          <a:bodyPr wrap="square" rtlCol="0">
+            <a:spAutoFit/>
+          </a:bodyPr>
+          <a:lstStyle/>
+          <a:p>
+            <a:pPr algn="ctr"/>
+            <a:r>
+              <a:rPr lang="en-US" sz="800" i="1" u="sng" dirty="0"/>
+              <a:t>Figure 4</a:t>
+            </a:r>
+            <a:r>
+              <a:rPr lang="en-US" sz="800" dirty="0"/>
+              <a:t>: Brownian Bridge trait reconstruction between </a:t>
+            </a:r>
+            <a:r>
+              <a:rPr lang="en-US" sz="800" dirty="0" err="1"/>
+              <a:t>Dasyurus</a:t>
+            </a:r>
+            <a:r>
+              <a:rPr lang="en-US" sz="800" dirty="0"/>
+              <a:t> maculatus and </a:t>
+            </a:r>
+            <a:r>
+              <a:rPr lang="en-US" sz="800" dirty="0" err="1"/>
+              <a:t>Dasyurus</a:t>
+            </a:r>
+            <a:r>
+              <a:rPr lang="en-US" sz="800" dirty="0"/>
+              <a:t> </a:t>
+            </a:r>
+            <a:r>
+              <a:rPr lang="en-US" sz="800" dirty="0" err="1"/>
+              <a:t>viverrinus</a:t>
+            </a:r>
+            <a:r>
+              <a:rPr lang="en-US" sz="800" dirty="0"/>
+              <a:t>. </a:t>
+            </a:r>
+            <a:r>
+              <a:rPr lang="en-US" sz="800" b="1" dirty="0"/>
+              <a:t>A) </a:t>
+            </a:r>
+            <a:r>
+              <a:rPr lang="en-US" sz="800" dirty="0"/>
+              <a:t>contributing Brownian Bridges</a:t>
+            </a:r>
+          </a:p>
+          <a:p>
+            <a:pPr algn="ctr"/>
+            <a:r>
+              <a:rPr lang="en-US" sz="800" dirty="0"/>
+              <a:t>to the ancestral trait value of the ancestor, red line indicates the time point of the ancestor </a:t>
+            </a:r>
+            <a:r>
+              <a:rPr lang="en-US" sz="800" b="1" dirty="0"/>
+              <a:t>B) </a:t>
+            </a:r>
+            <a:r>
+              <a:rPr lang="en-US" sz="800" dirty="0"/>
+              <a:t>kernel density estimates of the contributing</a:t>
+            </a:r>
+          </a:p>
+          <a:p>
+            <a:pPr algn="ctr"/>
+            <a:r>
+              <a:rPr lang="en-US" sz="800" dirty="0"/>
+              <a:t>leaves to the resulting ancestral nodes, blue line corresponds to the density seen in figure </a:t>
+            </a:r>
+            <a:r>
+              <a:rPr lang="en-US" sz="800" b="1" dirty="0"/>
+              <a:t>A</a:t>
+            </a:r>
+            <a:endParaRPr lang="en-AU" sz="800" b="1" dirty="0"/>
+          </a:p>
+        </p:txBody>
+      </p:sp>
+      <p:sp>
+        <p:nvSpPr>
+          <p:cNvPr id="13" name="TextBox 12">
+            <a:extLst>
+              <a:ext uri="{FF2B5EF4-FFF2-40B4-BE49-F238E27FC236}">
+                <a16:creationId xmlns:a16="http://schemas.microsoft.com/office/drawing/2014/main" id="{46C4F6BF-44FF-C266-9E16-D0A6E9A6FB4F}"/>
+              </a:ext>
+            </a:extLst>
+          </p:cNvPr>
+          <p:cNvSpPr txBox="1"/>
+          <p:nvPr/>
+        </p:nvSpPr>
+        <p:spPr>
+          <a:xfrm>
+            <a:off x="6343826" y="872949"/>
+            <a:ext cx="432123" cy="369332"/>
+          </a:xfrm>
+          <a:prstGeom prst="rect">
+            <a:avLst/>
+          </a:prstGeom>
+          <a:noFill/>
+        </p:spPr>
+        <p:txBody>
+          <a:bodyPr wrap="square" rtlCol="0">
+            <a:spAutoFit/>
+          </a:bodyPr>
+          <a:lstStyle/>
+          <a:p>
+            <a:r>
+              <a:rPr lang="en-AU" b="1" dirty="0"/>
+              <a:t>A</a:t>
+            </a:r>
+          </a:p>
+        </p:txBody>
+      </p:sp>
+      <p:sp>
+        <p:nvSpPr>
+          <p:cNvPr id="15" name="TextBox 14">
+            <a:extLst>
+              <a:ext uri="{FF2B5EF4-FFF2-40B4-BE49-F238E27FC236}">
+                <a16:creationId xmlns:a16="http://schemas.microsoft.com/office/drawing/2014/main" id="{60E80DBE-9086-39D4-2676-68F92E9ACA6D}"/>
+              </a:ext>
+            </a:extLst>
+          </p:cNvPr>
+          <p:cNvSpPr txBox="1"/>
+          <p:nvPr/>
+        </p:nvSpPr>
+        <p:spPr>
+          <a:xfrm>
+            <a:off x="6434089" y="3409848"/>
+            <a:ext cx="432123" cy="369332"/>
+          </a:xfrm>
+          <a:prstGeom prst="rect">
+            <a:avLst/>
+          </a:prstGeom>
+          <a:noFill/>
+        </p:spPr>
+        <p:txBody>
+          <a:bodyPr wrap="square" rtlCol="0">
+            <a:spAutoFit/>
+          </a:bodyPr>
+          <a:lstStyle/>
+          <a:p>
+            <a:r>
+              <a:rPr lang="en-AU" b="1" dirty="0"/>
+              <a:t>B</a:t>
+            </a:r>
+          </a:p>
+        </p:txBody>
+      </p:sp>
+    </p:spTree>
+    <p:extLst>
+      <p:ext uri="{BB962C8B-B14F-4D97-AF65-F5344CB8AC3E}">
+        <p14:creationId xmlns:p14="http://schemas.microsoft.com/office/powerpoint/2010/main" val="797725360"/>
       </p:ext>
     </p:extLst>
   </p:cSld>
@@ -33243,18 +33742,18 @@
       </p:grpSpPr>
       <p:sp>
         <p:nvSpPr>
-          <p:cNvPr id="2" name="Footer Placeholder 1">
-            <a:extLst>
-              <a:ext uri="{FF2B5EF4-FFF2-40B4-BE49-F238E27FC236}">
-                <a16:creationId xmlns:a16="http://schemas.microsoft.com/office/drawing/2014/main" id="{79A1B4B0-6FEA-5EB3-7B9A-7B3CC7BEAE3F}"/>
-              </a:ext>
-            </a:extLst>
-          </p:cNvPr>
-          <p:cNvSpPr>
-            <a:spLocks noGrp="1"/>
-          </p:cNvSpPr>
-          <p:nvPr>
-            <p:ph type="ftr" sz="quarter" idx="17"/>
+          <p:cNvPr id="2" name="Picture Placeholder 1">
+            <a:extLst>
+              <a:ext uri="{FF2B5EF4-FFF2-40B4-BE49-F238E27FC236}">
+                <a16:creationId xmlns:a16="http://schemas.microsoft.com/office/drawing/2014/main" id="{DCA3647C-7FCF-2E97-0FDE-7ACAD643FB65}"/>
+              </a:ext>
+            </a:extLst>
+          </p:cNvPr>
+          <p:cNvSpPr>
+            <a:spLocks noGrp="1"/>
+          </p:cNvSpPr>
+          <p:nvPr>
+            <p:ph type="pic" sz="quarter" idx="23"/>
           </p:nvPr>
         </p:nvSpPr>
         <p:spPr/>
@@ -33262,24 +33761,49 @@
           <a:bodyPr/>
           <a:lstStyle/>
           <a:p>
+            <a:endParaRPr lang="en-AU"/>
+          </a:p>
+        </p:txBody>
+      </p:sp>
+      <p:sp>
+        <p:nvSpPr>
+          <p:cNvPr id="3" name="Footer Placeholder 2">
+            <a:extLst>
+              <a:ext uri="{FF2B5EF4-FFF2-40B4-BE49-F238E27FC236}">
+                <a16:creationId xmlns:a16="http://schemas.microsoft.com/office/drawing/2014/main" id="{0C93980C-7FC7-1AE2-7CB3-3551FCA3090E}"/>
+              </a:ext>
+            </a:extLst>
+          </p:cNvPr>
+          <p:cNvSpPr>
+            <a:spLocks noGrp="1"/>
+          </p:cNvSpPr>
+          <p:nvPr>
+            <p:ph type="ftr" sz="quarter" idx="15"/>
+          </p:nvPr>
+        </p:nvSpPr>
+        <p:spPr/>
+        <p:txBody>
+          <a:bodyPr/>
+          <a:lstStyle/>
+          <a:p>
             <a:endParaRPr lang="en-AU" dirty="0"/>
           </a:p>
         </p:txBody>
       </p:sp>
       <p:sp>
         <p:nvSpPr>
-          <p:cNvPr id="3" name="Slide Number Placeholder 2">
-            <a:extLst>
-              <a:ext uri="{FF2B5EF4-FFF2-40B4-BE49-F238E27FC236}">
-                <a16:creationId xmlns:a16="http://schemas.microsoft.com/office/drawing/2014/main" id="{C9977004-3AF6-9F96-87A0-489CCE84F8B8}"/>
-              </a:ext>
-            </a:extLst>
-          </p:cNvPr>
-          <p:cNvSpPr>
-            <a:spLocks noGrp="1"/>
-          </p:cNvSpPr>
-          <p:nvPr>
-            <p:ph type="sldNum" sz="quarter" idx="18"/>
+          <p:cNvPr id="4" name="Slide Number Placeholder 3">
+            <a:extLst>
+              <a:ext uri="{FF2B5EF4-FFF2-40B4-BE49-F238E27FC236}">
+                <a16:creationId xmlns:a16="http://schemas.microsoft.com/office/drawing/2014/main" id="{A8CF36DA-0617-5A31-C756-10AA85E737F8}"/>
+              </a:ext>
+            </a:extLst>
+          </p:cNvPr>
+          <p:cNvSpPr>
+            <a:spLocks noGrp="1"/>
+          </p:cNvSpPr>
+          <p:nvPr>
+            <p:ph type="sldNum" sz="quarter" idx="16"/>
           </p:nvPr>
         </p:nvSpPr>
         <p:spPr/>
@@ -33291,6 +33815,1113 @@
               <a:rPr lang="en-AU" smtClean="0"/>
               <a:pPr/>
               <a:t>2</a:t>
+            </a:fld>
+            <a:endParaRPr lang="en-AU" dirty="0"/>
+          </a:p>
+        </p:txBody>
+      </p:sp>
+      <p:sp>
+        <p:nvSpPr>
+          <p:cNvPr id="5" name="Content Placeholder 4">
+            <a:extLst>
+              <a:ext uri="{FF2B5EF4-FFF2-40B4-BE49-F238E27FC236}">
+                <a16:creationId xmlns:a16="http://schemas.microsoft.com/office/drawing/2014/main" id="{C490FB33-6537-C8CF-CF0B-80C4815DDCED}"/>
+              </a:ext>
+            </a:extLst>
+          </p:cNvPr>
+          <p:cNvSpPr>
+            <a:spLocks noGrp="1"/>
+          </p:cNvSpPr>
+          <p:nvPr>
+            <p:ph sz="quarter" idx="24"/>
+          </p:nvPr>
+        </p:nvSpPr>
+        <p:spPr/>
+        <p:txBody>
+          <a:bodyPr/>
+          <a:lstStyle/>
+          <a:p>
+            <a:endParaRPr lang="en-AU"/>
+          </a:p>
+        </p:txBody>
+      </p:sp>
+      <p:sp>
+        <p:nvSpPr>
+          <p:cNvPr id="6" name="Title 5">
+            <a:extLst>
+              <a:ext uri="{FF2B5EF4-FFF2-40B4-BE49-F238E27FC236}">
+                <a16:creationId xmlns:a16="http://schemas.microsoft.com/office/drawing/2014/main" id="{AE266984-0566-964E-F874-7F7FE5D74E54}"/>
+              </a:ext>
+            </a:extLst>
+          </p:cNvPr>
+          <p:cNvSpPr>
+            <a:spLocks noGrp="1"/>
+          </p:cNvSpPr>
+          <p:nvPr>
+            <p:ph type="title"/>
+          </p:nvPr>
+        </p:nvSpPr>
+        <p:spPr/>
+        <p:txBody>
+          <a:bodyPr/>
+          <a:lstStyle/>
+          <a:p>
+            <a:r>
+              <a:rPr lang="en-AU" dirty="0"/>
+              <a:t>Who Am I?</a:t>
+            </a:r>
+          </a:p>
+        </p:txBody>
+      </p:sp>
+      <p:sp>
+        <p:nvSpPr>
+          <p:cNvPr id="7" name="Text Placeholder 6">
+            <a:extLst>
+              <a:ext uri="{FF2B5EF4-FFF2-40B4-BE49-F238E27FC236}">
+                <a16:creationId xmlns:a16="http://schemas.microsoft.com/office/drawing/2014/main" id="{0943C3C2-F771-CE23-AADF-FA90F5740ACB}"/>
+              </a:ext>
+            </a:extLst>
+          </p:cNvPr>
+          <p:cNvSpPr>
+            <a:spLocks noGrp="1"/>
+          </p:cNvSpPr>
+          <p:nvPr>
+            <p:ph type="body" sz="quarter" idx="31"/>
+          </p:nvPr>
+        </p:nvSpPr>
+        <p:spPr/>
+        <p:txBody>
+          <a:bodyPr/>
+          <a:lstStyle/>
+          <a:p>
+            <a:endParaRPr lang="en-AU"/>
+          </a:p>
+        </p:txBody>
+      </p:sp>
+    </p:spTree>
+    <p:extLst>
+      <p:ext uri="{BB962C8B-B14F-4D97-AF65-F5344CB8AC3E}">
+        <p14:creationId xmlns:p14="http://schemas.microsoft.com/office/powerpoint/2010/main" val="2537764727"/>
+      </p:ext>
+    </p:extLst>
+  </p:cSld>
+  <p:clrMapOvr>
+    <a:masterClrMapping/>
+  </p:clrMapOvr>
+  <mc:AlternateContent xmlns:mc="http://schemas.openxmlformats.org/markup-compatibility/2006" xmlns:p14="http://schemas.microsoft.com/office/powerpoint/2010/main">
+    <mc:Choice Requires="p14">
+      <p:transition spd="med" p14:dur="700">
+        <p:fade/>
+      </p:transition>
+    </mc:Choice>
+    <mc:Fallback xmlns="">
+      <p:transition spd="med">
+        <p:fade/>
+      </p:transition>
+    </mc:Fallback>
+  </mc:AlternateContent>
+</p:sld>
+</file>
+
+<file path=ppt/slides/slide3.xml><?xml version="1.0" encoding="utf-8"?>
+<p:sld xmlns:a="http://schemas.openxmlformats.org/drawingml/2006/main" xmlns:r="http://schemas.openxmlformats.org/officeDocument/2006/relationships" xmlns:p="http://schemas.openxmlformats.org/presentationml/2006/main">
+  <p:cSld>
+    <p:spTree>
+      <p:nvGrpSpPr>
+        <p:cNvPr id="1" name=""/>
+        <p:cNvGrpSpPr/>
+        <p:nvPr/>
+      </p:nvGrpSpPr>
+      <p:grpSpPr>
+        <a:xfrm>
+          <a:off x="0" y="0"/>
+          <a:ext cx="0" cy="0"/>
+          <a:chOff x="0" y="0"/>
+          <a:chExt cx="0" cy="0"/>
+        </a:xfrm>
+      </p:grpSpPr>
+      <p:sp>
+        <p:nvSpPr>
+          <p:cNvPr id="20" name="Footer Placeholder 1">
+            <a:extLst>
+              <a:ext uri="{FF2B5EF4-FFF2-40B4-BE49-F238E27FC236}">
+                <a16:creationId xmlns:a16="http://schemas.microsoft.com/office/drawing/2014/main" id="{2E3E92E9-0213-5D24-FC53-CE3C59CF2C8E}"/>
+              </a:ext>
+            </a:extLst>
+          </p:cNvPr>
+          <p:cNvSpPr>
+            <a:spLocks noGrp="1"/>
+          </p:cNvSpPr>
+          <p:nvPr>
+            <p:ph type="ftr" sz="quarter" idx="17"/>
+          </p:nvPr>
+        </p:nvSpPr>
+        <p:spPr>
+          <a:xfrm>
+            <a:off x="695326" y="6526800"/>
+            <a:ext cx="3360109" cy="108000"/>
+          </a:xfrm>
+        </p:spPr>
+        <p:txBody>
+          <a:bodyPr/>
+          <a:lstStyle/>
+          <a:p>
+            <a:endParaRPr lang="en-AU"/>
+          </a:p>
+        </p:txBody>
+      </p:sp>
+      <p:sp>
+        <p:nvSpPr>
+          <p:cNvPr id="6" name="Slide Number Placeholder 5">
+            <a:extLst>
+              <a:ext uri="{FF2B5EF4-FFF2-40B4-BE49-F238E27FC236}">
+                <a16:creationId xmlns:a16="http://schemas.microsoft.com/office/drawing/2014/main" id="{D898EF18-08B1-0652-0F96-8A5EF4A613C2}"/>
+              </a:ext>
+            </a:extLst>
+          </p:cNvPr>
+          <p:cNvSpPr>
+            <a:spLocks noGrp="1"/>
+          </p:cNvSpPr>
+          <p:nvPr>
+            <p:ph type="sldNum" sz="quarter" idx="18"/>
+          </p:nvPr>
+        </p:nvSpPr>
+        <p:spPr>
+          <a:xfrm>
+            <a:off x="11208568" y="6526800"/>
+            <a:ext cx="288032" cy="108000"/>
+          </a:xfrm>
+        </p:spPr>
+        <p:txBody>
+          <a:bodyPr anchor="ctr">
+            <a:normAutofit/>
+          </a:bodyPr>
+          <a:lstStyle/>
+          <a:p>
+            <a:pPr>
+              <a:spcAft>
+                <a:spcPts val="600"/>
+              </a:spcAft>
+            </a:pPr>
+            <a:fld id="{E917DE0E-AFB1-41FD-BC35-27DB61CA125F}" type="slidenum">
+              <a:rPr lang="en-AU" sz="700" smtClean="0"/>
+              <a:pPr>
+                <a:spcAft>
+                  <a:spcPts val="600"/>
+                </a:spcAft>
+              </a:pPr>
+              <a:t>3</a:t>
+            </a:fld>
+            <a:endParaRPr lang="en-AU" sz="700"/>
+          </a:p>
+        </p:txBody>
+      </p:sp>
+      <p:sp>
+        <p:nvSpPr>
+          <p:cNvPr id="22" name="Title 3">
+            <a:extLst>
+              <a:ext uri="{FF2B5EF4-FFF2-40B4-BE49-F238E27FC236}">
+                <a16:creationId xmlns:a16="http://schemas.microsoft.com/office/drawing/2014/main" id="{C4B956DC-56C2-EC63-D24B-F4C8AD308211}"/>
+              </a:ext>
+            </a:extLst>
+          </p:cNvPr>
+          <p:cNvSpPr>
+            <a:spLocks noGrp="1"/>
+          </p:cNvSpPr>
+          <p:nvPr>
+            <p:ph type="title"/>
+          </p:nvPr>
+        </p:nvSpPr>
+        <p:spPr>
+          <a:xfrm>
+            <a:off x="695326" y="982800"/>
+            <a:ext cx="3384550" cy="1654112"/>
+          </a:xfrm>
+        </p:spPr>
+        <p:txBody>
+          <a:bodyPr/>
+          <a:lstStyle/>
+          <a:p>
+            <a:r>
+              <a:rPr lang="en-US" dirty="0"/>
+              <a:t>The Problem</a:t>
+            </a:r>
+          </a:p>
+        </p:txBody>
+      </p:sp>
+      <p:sp>
+        <p:nvSpPr>
+          <p:cNvPr id="8" name="Text Placeholder 7">
+            <a:extLst>
+              <a:ext uri="{FF2B5EF4-FFF2-40B4-BE49-F238E27FC236}">
+                <a16:creationId xmlns:a16="http://schemas.microsoft.com/office/drawing/2014/main" id="{4366A5BC-8E33-D478-8894-22B7A6E0F806}"/>
+              </a:ext>
+            </a:extLst>
+          </p:cNvPr>
+          <p:cNvSpPr>
+            <a:spLocks noGrp="1"/>
+          </p:cNvSpPr>
+          <p:nvPr>
+            <p:ph type="body" sz="quarter" idx="31"/>
+          </p:nvPr>
+        </p:nvSpPr>
+        <p:spPr>
+          <a:xfrm>
+            <a:off x="695326" y="2816920"/>
+            <a:ext cx="3384550" cy="3056550"/>
+          </a:xfrm>
+        </p:spPr>
+        <p:txBody>
+          <a:bodyPr>
+            <a:normAutofit/>
+          </a:bodyPr>
+          <a:lstStyle/>
+          <a:p>
+            <a:endParaRPr lang="en-AU" dirty="0"/>
+          </a:p>
+        </p:txBody>
+      </p:sp>
+      <p:pic>
+        <p:nvPicPr>
+          <p:cNvPr id="18" name="Content Placeholder 8">
+            <a:extLst>
+              <a:ext uri="{FF2B5EF4-FFF2-40B4-BE49-F238E27FC236}">
+                <a16:creationId xmlns:a16="http://schemas.microsoft.com/office/drawing/2014/main" id="{33F26D38-27BC-65AC-90E2-29FD2D905FD5}"/>
+              </a:ext>
+            </a:extLst>
+          </p:cNvPr>
+          <p:cNvPicPr>
+            <a:picLocks noChangeAspect="1"/>
+          </p:cNvPicPr>
+          <p:nvPr/>
+        </p:nvPicPr>
+        <p:blipFill>
+          <a:blip r:embed="rId2"/>
+          <a:stretch>
+            <a:fillRect/>
+          </a:stretch>
+        </p:blipFill>
+        <p:spPr>
+          <a:xfrm>
+            <a:off x="4223793" y="970718"/>
+            <a:ext cx="7552950" cy="5200111"/>
+          </a:xfrm>
+          <a:prstGeom prst="rect">
+            <a:avLst/>
+          </a:prstGeom>
+        </p:spPr>
+      </p:pic>
+    </p:spTree>
+    <p:extLst>
+      <p:ext uri="{BB962C8B-B14F-4D97-AF65-F5344CB8AC3E}">
+        <p14:creationId xmlns:p14="http://schemas.microsoft.com/office/powerpoint/2010/main" val="2434168867"/>
+      </p:ext>
+    </p:extLst>
+  </p:cSld>
+  <p:clrMapOvr>
+    <a:masterClrMapping/>
+  </p:clrMapOvr>
+  <mc:AlternateContent xmlns:mc="http://schemas.openxmlformats.org/markup-compatibility/2006" xmlns:p14="http://schemas.microsoft.com/office/powerpoint/2010/main">
+    <mc:Choice Requires="p14">
+      <p:transition spd="med" p14:dur="700">
+        <p:fade/>
+      </p:transition>
+    </mc:Choice>
+    <mc:Fallback xmlns="">
+      <p:transition spd="med">
+        <p:fade/>
+      </p:transition>
+    </mc:Fallback>
+  </mc:AlternateContent>
+</p:sld>
+</file>
+
+<file path=ppt/slides/slide4.xml><?xml version="1.0" encoding="utf-8"?>
+<p:sld xmlns:a="http://schemas.openxmlformats.org/drawingml/2006/main" xmlns:r="http://schemas.openxmlformats.org/officeDocument/2006/relationships" xmlns:p="http://schemas.openxmlformats.org/presentationml/2006/main">
+  <p:cSld>
+    <p:spTree>
+      <p:nvGrpSpPr>
+        <p:cNvPr id="1" name=""/>
+        <p:cNvGrpSpPr/>
+        <p:nvPr/>
+      </p:nvGrpSpPr>
+      <p:grpSpPr>
+        <a:xfrm>
+          <a:off x="0" y="0"/>
+          <a:ext cx="0" cy="0"/>
+          <a:chOff x="0" y="0"/>
+          <a:chExt cx="0" cy="0"/>
+        </a:xfrm>
+      </p:grpSpPr>
+      <p:sp>
+        <p:nvSpPr>
+          <p:cNvPr id="2" name="Footer Placeholder 1">
+            <a:extLst>
+              <a:ext uri="{FF2B5EF4-FFF2-40B4-BE49-F238E27FC236}">
+                <a16:creationId xmlns:a16="http://schemas.microsoft.com/office/drawing/2014/main" id="{5BEC7ABA-9848-506C-6F27-238ACEF55801}"/>
+              </a:ext>
+            </a:extLst>
+          </p:cNvPr>
+          <p:cNvSpPr>
+            <a:spLocks noGrp="1"/>
+          </p:cNvSpPr>
+          <p:nvPr>
+            <p:ph type="ftr" sz="quarter" idx="17"/>
+          </p:nvPr>
+        </p:nvSpPr>
+        <p:spPr/>
+        <p:txBody>
+          <a:bodyPr/>
+          <a:lstStyle/>
+          <a:p>
+            <a:endParaRPr lang="en-AU" dirty="0"/>
+          </a:p>
+        </p:txBody>
+      </p:sp>
+      <p:sp>
+        <p:nvSpPr>
+          <p:cNvPr id="3" name="Slide Number Placeholder 2">
+            <a:extLst>
+              <a:ext uri="{FF2B5EF4-FFF2-40B4-BE49-F238E27FC236}">
+                <a16:creationId xmlns:a16="http://schemas.microsoft.com/office/drawing/2014/main" id="{5185B863-AD6F-4035-A9E2-F55ED2057B18}"/>
+              </a:ext>
+            </a:extLst>
+          </p:cNvPr>
+          <p:cNvSpPr>
+            <a:spLocks noGrp="1"/>
+          </p:cNvSpPr>
+          <p:nvPr>
+            <p:ph type="sldNum" sz="quarter" idx="18"/>
+          </p:nvPr>
+        </p:nvSpPr>
+        <p:spPr/>
+        <p:txBody>
+          <a:bodyPr/>
+          <a:lstStyle/>
+          <a:p>
+            <a:fld id="{E917DE0E-AFB1-41FD-BC35-27DB61CA125F}" type="slidenum">
+              <a:rPr lang="en-AU" smtClean="0"/>
+              <a:pPr/>
+              <a:t>4</a:t>
+            </a:fld>
+            <a:endParaRPr lang="en-AU" dirty="0"/>
+          </a:p>
+        </p:txBody>
+      </p:sp>
+      <p:sp>
+        <p:nvSpPr>
+          <p:cNvPr id="4" name="Content Placeholder 3">
+            <a:extLst>
+              <a:ext uri="{FF2B5EF4-FFF2-40B4-BE49-F238E27FC236}">
+                <a16:creationId xmlns:a16="http://schemas.microsoft.com/office/drawing/2014/main" id="{FF5DFF1D-DC61-98D5-4658-6FD46DA506EC}"/>
+              </a:ext>
+            </a:extLst>
+          </p:cNvPr>
+          <p:cNvSpPr>
+            <a:spLocks noGrp="1"/>
+          </p:cNvSpPr>
+          <p:nvPr>
+            <p:ph sz="quarter" idx="10"/>
+          </p:nvPr>
+        </p:nvSpPr>
+        <p:spPr/>
+        <p:txBody>
+          <a:bodyPr/>
+          <a:lstStyle/>
+          <a:p>
+            <a:pPr marL="285750" indent="-285750">
+              <a:buFont typeface="Arial" panose="020B0604020202020204" pitchFamily="34" charset="0"/>
+              <a:buChar char="•"/>
+            </a:pPr>
+            <a:r>
+              <a:rPr lang="en-AU" dirty="0"/>
+              <a:t>A Brief History of </a:t>
+            </a:r>
+            <a:r>
+              <a:rPr lang="en-AU" i="1" dirty="0"/>
+              <a:t>Panthera </a:t>
+            </a:r>
+            <a:r>
+              <a:rPr lang="en-AU" i="1" dirty="0" err="1"/>
+              <a:t>tigris</a:t>
+            </a:r>
+            <a:endParaRPr lang="en-AU" i="1" dirty="0"/>
+          </a:p>
+          <a:p>
+            <a:pPr marL="465750" lvl="2" indent="-285750"/>
+            <a:r>
+              <a:rPr lang="en-AU" sz="1100" dirty="0"/>
+              <a:t>1758 Carl Linnaeus describes the tiger giving it the scientific name </a:t>
+            </a:r>
+            <a:r>
+              <a:rPr lang="en-AU" sz="1100" i="1" dirty="0"/>
+              <a:t>Felis </a:t>
+            </a:r>
+            <a:r>
+              <a:rPr lang="en-AU" sz="1100" i="1" dirty="0" err="1"/>
+              <a:t>tigris</a:t>
+            </a:r>
+            <a:endParaRPr lang="en-AU" sz="1100" i="1" dirty="0"/>
+          </a:p>
+          <a:p>
+            <a:pPr marL="465750" lvl="2" indent="-285750"/>
+            <a:r>
+              <a:rPr lang="en-AU" sz="1100" dirty="0"/>
+              <a:t>1929 Reginald Innes Pocock places the species in </a:t>
+            </a:r>
+            <a:r>
+              <a:rPr lang="en-AU" sz="1100" i="1" dirty="0"/>
+              <a:t>Panthera</a:t>
+            </a:r>
+          </a:p>
+          <a:p>
+            <a:pPr marL="742950" lvl="3" indent="-285750"/>
+            <a:r>
+              <a:rPr lang="en-AU" sz="1100" dirty="0"/>
+              <a:t>We recognize up to 9 (Living and Extinct) tiger subspecies: Bengal, Malayan, Indochinese, South China, Siberian, Caspian, Javan, Bali, Sumatran</a:t>
+            </a:r>
+          </a:p>
+          <a:p>
+            <a:pPr marL="465750" lvl="2" indent="-285750"/>
+            <a:r>
+              <a:rPr lang="en-AU" sz="1100" dirty="0"/>
+              <a:t>1999 Proposal to recognize only 2 subspecies as previous definitions rely solely on morphological characteristics</a:t>
+            </a:r>
+          </a:p>
+          <a:p>
+            <a:pPr marL="742950" lvl="3" indent="-285750"/>
+            <a:r>
+              <a:rPr lang="en-AU" sz="1100" i="1" dirty="0"/>
+              <a:t>Panthera </a:t>
+            </a:r>
+            <a:r>
+              <a:rPr lang="en-AU" sz="1100" i="1" dirty="0" err="1"/>
+              <a:t>tigris</a:t>
+            </a:r>
+            <a:r>
+              <a:rPr lang="en-AU" sz="1100" i="1" dirty="0"/>
+              <a:t> </a:t>
+            </a:r>
+            <a:r>
+              <a:rPr lang="en-AU" sz="1100" i="1" dirty="0" err="1"/>
+              <a:t>tigris</a:t>
+            </a:r>
+            <a:r>
+              <a:rPr lang="en-AU" sz="1100" i="1" dirty="0"/>
+              <a:t>, Panthera </a:t>
+            </a:r>
+            <a:r>
+              <a:rPr lang="en-AU" sz="1100" i="1" dirty="0" err="1"/>
+              <a:t>tigris</a:t>
+            </a:r>
+            <a:r>
+              <a:rPr lang="en-AU" sz="1100" i="1" dirty="0"/>
+              <a:t> </a:t>
+            </a:r>
+            <a:r>
+              <a:rPr lang="en-AU" sz="1100" i="1" dirty="0" err="1"/>
+              <a:t>sondaica</a:t>
+            </a:r>
+            <a:endParaRPr lang="en-AU" sz="1100" i="1" dirty="0"/>
+          </a:p>
+          <a:p>
+            <a:pPr marL="465750" lvl="2" indent="-285750"/>
+            <a:r>
+              <a:rPr lang="en-AU" sz="1100" dirty="0"/>
+              <a:t>2015 corroboration of two subspecies proposal due to morphological, ecological and </a:t>
+            </a:r>
+            <a:r>
+              <a:rPr lang="en-AU" sz="1100" dirty="0" err="1"/>
+              <a:t>mitochrondrial</a:t>
+            </a:r>
+            <a:r>
+              <a:rPr lang="en-AU" sz="1100" dirty="0"/>
+              <a:t> DNA traits</a:t>
+            </a:r>
+          </a:p>
+          <a:p>
+            <a:pPr marL="465750" lvl="2" indent="-285750"/>
+            <a:r>
+              <a:rPr lang="en-AU" sz="1100" dirty="0"/>
+              <a:t>2018 whole genome sequencing on the 6 remaining subspecies from 1929-1999 definitions indicate all belong to different clades</a:t>
+            </a:r>
+          </a:p>
+          <a:p>
+            <a:pPr marL="742950" lvl="3" indent="-285750"/>
+            <a:r>
+              <a:rPr lang="en-AU" sz="1100" dirty="0"/>
+              <a:t>Corroborated in 2021, 2023</a:t>
+            </a:r>
+          </a:p>
+          <a:p>
+            <a:pPr marL="286362" lvl="1" indent="-285750"/>
+            <a:endParaRPr lang="en-AU" i="1" dirty="0"/>
+          </a:p>
+          <a:p>
+            <a:pPr marL="286362" lvl="1" indent="-285750"/>
+            <a:endParaRPr lang="en-AU" i="1" dirty="0"/>
+          </a:p>
+          <a:p>
+            <a:pPr marL="465750" lvl="2" indent="-285750"/>
+            <a:endParaRPr lang="en-AU" dirty="0"/>
+          </a:p>
+        </p:txBody>
+      </p:sp>
+      <p:sp>
+        <p:nvSpPr>
+          <p:cNvPr id="5" name="Title 4">
+            <a:extLst>
+              <a:ext uri="{FF2B5EF4-FFF2-40B4-BE49-F238E27FC236}">
+                <a16:creationId xmlns:a16="http://schemas.microsoft.com/office/drawing/2014/main" id="{0EC7A32B-F1E6-BBD6-2FD8-FAE19238C0A9}"/>
+              </a:ext>
+            </a:extLst>
+          </p:cNvPr>
+          <p:cNvSpPr>
+            <a:spLocks noGrp="1"/>
+          </p:cNvSpPr>
+          <p:nvPr>
+            <p:ph type="title"/>
+          </p:nvPr>
+        </p:nvSpPr>
+        <p:spPr/>
+        <p:txBody>
+          <a:bodyPr/>
+          <a:lstStyle/>
+          <a:p>
+            <a:r>
+              <a:rPr lang="en-AU" dirty="0"/>
+              <a:t>What is a Species?</a:t>
+            </a:r>
+          </a:p>
+        </p:txBody>
+      </p:sp>
+      <p:sp>
+        <p:nvSpPr>
+          <p:cNvPr id="6" name="Text Placeholder 5">
+            <a:extLst>
+              <a:ext uri="{FF2B5EF4-FFF2-40B4-BE49-F238E27FC236}">
+                <a16:creationId xmlns:a16="http://schemas.microsoft.com/office/drawing/2014/main" id="{7AEAD64D-8A93-EE1C-B46B-499B68C03359}"/>
+              </a:ext>
+            </a:extLst>
+          </p:cNvPr>
+          <p:cNvSpPr>
+            <a:spLocks noGrp="1"/>
+          </p:cNvSpPr>
+          <p:nvPr>
+            <p:ph type="body" sz="quarter" idx="31"/>
+          </p:nvPr>
+        </p:nvSpPr>
+        <p:spPr/>
+        <p:txBody>
+          <a:bodyPr/>
+          <a:lstStyle/>
+          <a:p>
+            <a:r>
+              <a:rPr lang="en-AU" dirty="0"/>
+              <a:t>And who gets to decide?</a:t>
+            </a:r>
+          </a:p>
+        </p:txBody>
+      </p:sp>
+      <p:sp>
+        <p:nvSpPr>
+          <p:cNvPr id="7" name="Content Placeholder 6">
+            <a:extLst>
+              <a:ext uri="{FF2B5EF4-FFF2-40B4-BE49-F238E27FC236}">
+                <a16:creationId xmlns:a16="http://schemas.microsoft.com/office/drawing/2014/main" id="{EF3E386D-4572-1273-0F17-950CF8632B0F}"/>
+              </a:ext>
+            </a:extLst>
+          </p:cNvPr>
+          <p:cNvSpPr>
+            <a:spLocks noGrp="1"/>
+          </p:cNvSpPr>
+          <p:nvPr>
+            <p:ph sz="quarter" idx="32"/>
+          </p:nvPr>
+        </p:nvSpPr>
+        <p:spPr/>
+        <p:txBody>
+          <a:bodyPr/>
+          <a:lstStyle/>
+          <a:p>
+            <a:endParaRPr lang="en-AU" dirty="0"/>
+          </a:p>
+        </p:txBody>
+      </p:sp>
+    </p:spTree>
+    <p:extLst>
+      <p:ext uri="{BB962C8B-B14F-4D97-AF65-F5344CB8AC3E}">
+        <p14:creationId xmlns:p14="http://schemas.microsoft.com/office/powerpoint/2010/main" val="1258235928"/>
+      </p:ext>
+    </p:extLst>
+  </p:cSld>
+  <p:clrMapOvr>
+    <a:masterClrMapping/>
+  </p:clrMapOvr>
+  <mc:AlternateContent xmlns:mc="http://schemas.openxmlformats.org/markup-compatibility/2006" xmlns:p14="http://schemas.microsoft.com/office/powerpoint/2010/main">
+    <mc:Choice Requires="p14">
+      <p:transition spd="med" p14:dur="700">
+        <p:fade/>
+      </p:transition>
+    </mc:Choice>
+    <mc:Fallback xmlns="">
+      <p:transition spd="med">
+        <p:fade/>
+      </p:transition>
+    </mc:Fallback>
+  </mc:AlternateContent>
+</p:sld>
+</file>
+
+<file path=ppt/slides/slide5.xml><?xml version="1.0" encoding="utf-8"?>
+<p:sld xmlns:a="http://schemas.openxmlformats.org/drawingml/2006/main" xmlns:r="http://schemas.openxmlformats.org/officeDocument/2006/relationships" xmlns:p="http://schemas.openxmlformats.org/presentationml/2006/main">
+  <p:cSld>
+    <p:spTree>
+      <p:nvGrpSpPr>
+        <p:cNvPr id="1" name=""/>
+        <p:cNvGrpSpPr/>
+        <p:nvPr/>
+      </p:nvGrpSpPr>
+      <p:grpSpPr>
+        <a:xfrm>
+          <a:off x="0" y="0"/>
+          <a:ext cx="0" cy="0"/>
+          <a:chOff x="0" y="0"/>
+          <a:chExt cx="0" cy="0"/>
+        </a:xfrm>
+      </p:grpSpPr>
+      <p:pic>
+        <p:nvPicPr>
+          <p:cNvPr id="8" name="Content Placeholder 7">
+            <a:extLst>
+              <a:ext uri="{FF2B5EF4-FFF2-40B4-BE49-F238E27FC236}">
+                <a16:creationId xmlns:a16="http://schemas.microsoft.com/office/drawing/2014/main" id="{9F7CF7A1-FF97-CD8B-A732-AACD76B7EC7A}"/>
+              </a:ext>
+            </a:extLst>
+          </p:cNvPr>
+          <p:cNvPicPr>
+            <a:picLocks noGrp="1" noChangeAspect="1"/>
+          </p:cNvPicPr>
+          <p:nvPr>
+            <p:ph sz="quarter" idx="10"/>
+          </p:nvPr>
+        </p:nvPicPr>
+        <p:blipFill>
+          <a:blip r:embed="rId2"/>
+          <a:stretch>
+            <a:fillRect/>
+          </a:stretch>
+        </p:blipFill>
+        <p:spPr>
+          <a:xfrm>
+            <a:off x="479376" y="1999232"/>
+            <a:ext cx="11425067" cy="3770016"/>
+          </a:xfrm>
+        </p:spPr>
+      </p:pic>
+      <p:sp>
+        <p:nvSpPr>
+          <p:cNvPr id="3" name="Title 2">
+            <a:extLst>
+              <a:ext uri="{FF2B5EF4-FFF2-40B4-BE49-F238E27FC236}">
+                <a16:creationId xmlns:a16="http://schemas.microsoft.com/office/drawing/2014/main" id="{473221EF-247C-D7D4-AB1B-DA880E505B5B}"/>
+              </a:ext>
+            </a:extLst>
+          </p:cNvPr>
+          <p:cNvSpPr>
+            <a:spLocks noGrp="1"/>
+          </p:cNvSpPr>
+          <p:nvPr>
+            <p:ph type="title"/>
+          </p:nvPr>
+        </p:nvSpPr>
+        <p:spPr/>
+        <p:txBody>
+          <a:bodyPr/>
+          <a:lstStyle/>
+          <a:p>
+            <a:r>
+              <a:rPr lang="en-AU" dirty="0"/>
+              <a:t>Trees	</a:t>
+            </a:r>
+          </a:p>
+        </p:txBody>
+      </p:sp>
+      <p:sp>
+        <p:nvSpPr>
+          <p:cNvPr id="4" name="Footer Placeholder 3">
+            <a:extLst>
+              <a:ext uri="{FF2B5EF4-FFF2-40B4-BE49-F238E27FC236}">
+                <a16:creationId xmlns:a16="http://schemas.microsoft.com/office/drawing/2014/main" id="{454541BD-15DC-3E8E-83F2-95C5D3EDD51B}"/>
+              </a:ext>
+            </a:extLst>
+          </p:cNvPr>
+          <p:cNvSpPr>
+            <a:spLocks noGrp="1"/>
+          </p:cNvSpPr>
+          <p:nvPr>
+            <p:ph type="ftr" sz="quarter" idx="17"/>
+          </p:nvPr>
+        </p:nvSpPr>
+        <p:spPr/>
+        <p:txBody>
+          <a:bodyPr/>
+          <a:lstStyle/>
+          <a:p>
+            <a:endParaRPr lang="en-AU" dirty="0"/>
+          </a:p>
+        </p:txBody>
+      </p:sp>
+      <p:sp>
+        <p:nvSpPr>
+          <p:cNvPr id="5" name="Slide Number Placeholder 4">
+            <a:extLst>
+              <a:ext uri="{FF2B5EF4-FFF2-40B4-BE49-F238E27FC236}">
+                <a16:creationId xmlns:a16="http://schemas.microsoft.com/office/drawing/2014/main" id="{F971501C-D520-9211-D6E4-0C2EDF3AC1E5}"/>
+              </a:ext>
+            </a:extLst>
+          </p:cNvPr>
+          <p:cNvSpPr>
+            <a:spLocks noGrp="1"/>
+          </p:cNvSpPr>
+          <p:nvPr>
+            <p:ph type="sldNum" sz="quarter" idx="18"/>
+          </p:nvPr>
+        </p:nvSpPr>
+        <p:spPr/>
+        <p:txBody>
+          <a:bodyPr/>
+          <a:lstStyle/>
+          <a:p>
+            <a:fld id="{E917DE0E-AFB1-41FD-BC35-27DB61CA125F}" type="slidenum">
+              <a:rPr lang="en-AU" smtClean="0"/>
+              <a:pPr/>
+              <a:t>5</a:t>
+            </a:fld>
+            <a:endParaRPr lang="en-AU" dirty="0"/>
+          </a:p>
+        </p:txBody>
+      </p:sp>
+      <p:sp>
+        <p:nvSpPr>
+          <p:cNvPr id="6" name="Text Placeholder 5">
+            <a:extLst>
+              <a:ext uri="{FF2B5EF4-FFF2-40B4-BE49-F238E27FC236}">
+                <a16:creationId xmlns:a16="http://schemas.microsoft.com/office/drawing/2014/main" id="{C4E191B5-C930-5F1D-FC4C-53154B8D4E9E}"/>
+              </a:ext>
+            </a:extLst>
+          </p:cNvPr>
+          <p:cNvSpPr>
+            <a:spLocks noGrp="1"/>
+          </p:cNvSpPr>
+          <p:nvPr>
+            <p:ph type="body" sz="quarter" idx="31"/>
+          </p:nvPr>
+        </p:nvSpPr>
+        <p:spPr/>
+        <p:txBody>
+          <a:bodyPr/>
+          <a:lstStyle/>
+          <a:p>
+            <a:r>
+              <a:rPr lang="en-AU" dirty="0"/>
+              <a:t>We’ll cross this bridge when we get to it</a:t>
+            </a:r>
+          </a:p>
+        </p:txBody>
+      </p:sp>
+    </p:spTree>
+    <p:extLst>
+      <p:ext uri="{BB962C8B-B14F-4D97-AF65-F5344CB8AC3E}">
+        <p14:creationId xmlns:p14="http://schemas.microsoft.com/office/powerpoint/2010/main" val="1494960421"/>
+      </p:ext>
+    </p:extLst>
+  </p:cSld>
+  <p:clrMapOvr>
+    <a:masterClrMapping/>
+  </p:clrMapOvr>
+  <mc:AlternateContent xmlns:mc="http://schemas.openxmlformats.org/markup-compatibility/2006" xmlns:p14="http://schemas.microsoft.com/office/powerpoint/2010/main">
+    <mc:Choice Requires="p14">
+      <p:transition spd="med" p14:dur="700">
+        <p:fade/>
+      </p:transition>
+    </mc:Choice>
+    <mc:Fallback xmlns="">
+      <p:transition spd="med">
+        <p:fade/>
+      </p:transition>
+    </mc:Fallback>
+  </mc:AlternateContent>
+</p:sld>
+</file>
+
+<file path=ppt/slides/slide6.xml><?xml version="1.0" encoding="utf-8"?>
+<p:sld xmlns:a="http://schemas.openxmlformats.org/drawingml/2006/main" xmlns:r="http://schemas.openxmlformats.org/officeDocument/2006/relationships" xmlns:p="http://schemas.openxmlformats.org/presentationml/2006/main">
+  <p:cSld>
+    <p:spTree>
+      <p:nvGrpSpPr>
+        <p:cNvPr id="1" name=""/>
+        <p:cNvGrpSpPr/>
+        <p:nvPr/>
+      </p:nvGrpSpPr>
+      <p:grpSpPr>
+        <a:xfrm>
+          <a:off x="0" y="0"/>
+          <a:ext cx="0" cy="0"/>
+          <a:chOff x="0" y="0"/>
+          <a:chExt cx="0" cy="0"/>
+        </a:xfrm>
+      </p:grpSpPr>
+      <p:sp>
+        <p:nvSpPr>
+          <p:cNvPr id="2" name="Footer Placeholder 1">
+            <a:extLst>
+              <a:ext uri="{FF2B5EF4-FFF2-40B4-BE49-F238E27FC236}">
+                <a16:creationId xmlns:a16="http://schemas.microsoft.com/office/drawing/2014/main" id="{49378074-02EA-32A9-01D3-7B5C4D0E38AA}"/>
+              </a:ext>
+            </a:extLst>
+          </p:cNvPr>
+          <p:cNvSpPr>
+            <a:spLocks noGrp="1"/>
+          </p:cNvSpPr>
+          <p:nvPr>
+            <p:ph type="ftr" sz="quarter" idx="17"/>
+          </p:nvPr>
+        </p:nvSpPr>
+        <p:spPr/>
+        <p:txBody>
+          <a:bodyPr/>
+          <a:lstStyle/>
+          <a:p>
+            <a:endParaRPr lang="en-AU" dirty="0"/>
+          </a:p>
+        </p:txBody>
+      </p:sp>
+      <p:sp>
+        <p:nvSpPr>
+          <p:cNvPr id="3" name="Slide Number Placeholder 2">
+            <a:extLst>
+              <a:ext uri="{FF2B5EF4-FFF2-40B4-BE49-F238E27FC236}">
+                <a16:creationId xmlns:a16="http://schemas.microsoft.com/office/drawing/2014/main" id="{A2AB8564-883E-4AF8-33FD-FE1587345221}"/>
+              </a:ext>
+            </a:extLst>
+          </p:cNvPr>
+          <p:cNvSpPr>
+            <a:spLocks noGrp="1"/>
+          </p:cNvSpPr>
+          <p:nvPr>
+            <p:ph type="sldNum" sz="quarter" idx="18"/>
+          </p:nvPr>
+        </p:nvSpPr>
+        <p:spPr/>
+        <p:txBody>
+          <a:bodyPr/>
+          <a:lstStyle/>
+          <a:p>
+            <a:fld id="{E917DE0E-AFB1-41FD-BC35-27DB61CA125F}" type="slidenum">
+              <a:rPr lang="en-AU" smtClean="0"/>
+              <a:pPr/>
+              <a:t>6</a:t>
+            </a:fld>
+            <a:endParaRPr lang="en-AU" dirty="0"/>
+          </a:p>
+        </p:txBody>
+      </p:sp>
+      <p:sp>
+        <p:nvSpPr>
+          <p:cNvPr id="4" name="Content Placeholder 3">
+            <a:extLst>
+              <a:ext uri="{FF2B5EF4-FFF2-40B4-BE49-F238E27FC236}">
+                <a16:creationId xmlns:a16="http://schemas.microsoft.com/office/drawing/2014/main" id="{6FC5BE12-DCC0-30EA-AC03-0D11DBD58858}"/>
+              </a:ext>
+            </a:extLst>
+          </p:cNvPr>
+          <p:cNvSpPr>
+            <a:spLocks noGrp="1"/>
+          </p:cNvSpPr>
+          <p:nvPr>
+            <p:ph sz="quarter" idx="10"/>
+          </p:nvPr>
+        </p:nvSpPr>
+        <p:spPr/>
+        <p:txBody>
+          <a:bodyPr/>
+          <a:lstStyle/>
+          <a:p>
+            <a:endParaRPr lang="en-AU"/>
+          </a:p>
+        </p:txBody>
+      </p:sp>
+      <p:sp>
+        <p:nvSpPr>
+          <p:cNvPr id="5" name="Title 4">
+            <a:extLst>
+              <a:ext uri="{FF2B5EF4-FFF2-40B4-BE49-F238E27FC236}">
+                <a16:creationId xmlns:a16="http://schemas.microsoft.com/office/drawing/2014/main" id="{61AEF317-97F4-037F-647D-E2B0021D88C5}"/>
+              </a:ext>
+            </a:extLst>
+          </p:cNvPr>
+          <p:cNvSpPr>
+            <a:spLocks noGrp="1"/>
+          </p:cNvSpPr>
+          <p:nvPr>
+            <p:ph type="title"/>
+          </p:nvPr>
+        </p:nvSpPr>
+        <p:spPr/>
+        <p:txBody>
+          <a:bodyPr/>
+          <a:lstStyle/>
+          <a:p>
+            <a:r>
+              <a:rPr lang="en-AU" dirty="0"/>
+              <a:t>The Problem</a:t>
+            </a:r>
+          </a:p>
+        </p:txBody>
+      </p:sp>
+      <p:sp>
+        <p:nvSpPr>
+          <p:cNvPr id="6" name="Text Placeholder 5">
+            <a:extLst>
+              <a:ext uri="{FF2B5EF4-FFF2-40B4-BE49-F238E27FC236}">
+                <a16:creationId xmlns:a16="http://schemas.microsoft.com/office/drawing/2014/main" id="{9DEA6735-6403-D3E0-E9F7-EF30B1E2B95F}"/>
+              </a:ext>
+            </a:extLst>
+          </p:cNvPr>
+          <p:cNvSpPr>
+            <a:spLocks noGrp="1"/>
+          </p:cNvSpPr>
+          <p:nvPr>
+            <p:ph type="body" sz="quarter" idx="31"/>
+          </p:nvPr>
+        </p:nvSpPr>
+        <p:spPr/>
+        <p:txBody>
+          <a:bodyPr/>
+          <a:lstStyle/>
+          <a:p>
+            <a:endParaRPr lang="en-AU"/>
+          </a:p>
+        </p:txBody>
+      </p:sp>
+      <p:sp>
+        <p:nvSpPr>
+          <p:cNvPr id="7" name="Content Placeholder 6">
+            <a:extLst>
+              <a:ext uri="{FF2B5EF4-FFF2-40B4-BE49-F238E27FC236}">
+                <a16:creationId xmlns:a16="http://schemas.microsoft.com/office/drawing/2014/main" id="{19184A45-C695-9E24-BBB2-7E261B9BE9B8}"/>
+              </a:ext>
+            </a:extLst>
+          </p:cNvPr>
+          <p:cNvSpPr>
+            <a:spLocks noGrp="1"/>
+          </p:cNvSpPr>
+          <p:nvPr>
+            <p:ph sz="quarter" idx="32"/>
+          </p:nvPr>
+        </p:nvSpPr>
+        <p:spPr/>
+        <p:txBody>
+          <a:bodyPr/>
+          <a:lstStyle/>
+          <a:p>
+            <a:endParaRPr lang="en-AU" dirty="0"/>
+          </a:p>
+        </p:txBody>
+      </p:sp>
+    </p:spTree>
+    <p:extLst>
+      <p:ext uri="{BB962C8B-B14F-4D97-AF65-F5344CB8AC3E}">
+        <p14:creationId xmlns:p14="http://schemas.microsoft.com/office/powerpoint/2010/main" val="1553256349"/>
+      </p:ext>
+    </p:extLst>
+  </p:cSld>
+  <p:clrMapOvr>
+    <a:masterClrMapping/>
+  </p:clrMapOvr>
+  <mc:AlternateContent xmlns:mc="http://schemas.openxmlformats.org/markup-compatibility/2006" xmlns:p14="http://schemas.microsoft.com/office/powerpoint/2010/main">
+    <mc:Choice Requires="p14">
+      <p:transition spd="med" p14:dur="700">
+        <p:fade/>
+      </p:transition>
+    </mc:Choice>
+    <mc:Fallback xmlns="">
+      <p:transition spd="med">
+        <p:fade/>
+      </p:transition>
+    </mc:Fallback>
+  </mc:AlternateContent>
+</p:sld>
+</file>
+
+<file path=ppt/slides/slide7.xml><?xml version="1.0" encoding="utf-8"?>
+<p:sld xmlns:a="http://schemas.openxmlformats.org/drawingml/2006/main" xmlns:r="http://schemas.openxmlformats.org/officeDocument/2006/relationships" xmlns:p="http://schemas.openxmlformats.org/presentationml/2006/main">
+  <p:cSld>
+    <p:spTree>
+      <p:nvGrpSpPr>
+        <p:cNvPr id="1" name=""/>
+        <p:cNvGrpSpPr/>
+        <p:nvPr/>
+      </p:nvGrpSpPr>
+      <p:grpSpPr>
+        <a:xfrm>
+          <a:off x="0" y="0"/>
+          <a:ext cx="0" cy="0"/>
+          <a:chOff x="0" y="0"/>
+          <a:chExt cx="0" cy="0"/>
+        </a:xfrm>
+      </p:grpSpPr>
+      <p:sp>
+        <p:nvSpPr>
+          <p:cNvPr id="2" name="Footer Placeholder 1">
+            <a:extLst>
+              <a:ext uri="{FF2B5EF4-FFF2-40B4-BE49-F238E27FC236}">
+                <a16:creationId xmlns:a16="http://schemas.microsoft.com/office/drawing/2014/main" id="{79A1B4B0-6FEA-5EB3-7B9A-7B3CC7BEAE3F}"/>
+              </a:ext>
+            </a:extLst>
+          </p:cNvPr>
+          <p:cNvSpPr>
+            <a:spLocks noGrp="1"/>
+          </p:cNvSpPr>
+          <p:nvPr>
+            <p:ph type="ftr" sz="quarter" idx="17"/>
+          </p:nvPr>
+        </p:nvSpPr>
+        <p:spPr/>
+        <p:txBody>
+          <a:bodyPr/>
+          <a:lstStyle/>
+          <a:p>
+            <a:endParaRPr lang="en-AU" dirty="0"/>
+          </a:p>
+        </p:txBody>
+      </p:sp>
+      <p:sp>
+        <p:nvSpPr>
+          <p:cNvPr id="3" name="Slide Number Placeholder 2">
+            <a:extLst>
+              <a:ext uri="{FF2B5EF4-FFF2-40B4-BE49-F238E27FC236}">
+                <a16:creationId xmlns:a16="http://schemas.microsoft.com/office/drawing/2014/main" id="{C9977004-3AF6-9F96-87A0-489CCE84F8B8}"/>
+              </a:ext>
+            </a:extLst>
+          </p:cNvPr>
+          <p:cNvSpPr>
+            <a:spLocks noGrp="1"/>
+          </p:cNvSpPr>
+          <p:nvPr>
+            <p:ph type="sldNum" sz="quarter" idx="18"/>
+          </p:nvPr>
+        </p:nvSpPr>
+        <p:spPr/>
+        <p:txBody>
+          <a:bodyPr/>
+          <a:lstStyle/>
+          <a:p>
+            <a:fld id="{E917DE0E-AFB1-41FD-BC35-27DB61CA125F}" type="slidenum">
+              <a:rPr lang="en-AU" smtClean="0"/>
+              <a:pPr/>
+              <a:t>7</a:t>
             </a:fld>
             <a:endParaRPr lang="en-AU" dirty="0"/>
           </a:p>
@@ -33573,7 +35204,7 @@
 </p:sld>
 </file>
 
-<file path=ppt/slides/slide3.xml><?xml version="1.0" encoding="utf-8"?>
+<file path=ppt/slides/slide8.xml><?xml version="1.0" encoding="utf-8"?>
 <p:sld xmlns:a="http://schemas.openxmlformats.org/drawingml/2006/main" xmlns:r="http://schemas.openxmlformats.org/officeDocument/2006/relationships" xmlns:p="http://schemas.openxmlformats.org/presentationml/2006/main">
   <p:cSld>
     <p:spTree>
@@ -34225,7 +35856,7 @@
                   <a:spcPts val="600"/>
                 </a:spcAft>
               </a:pPr>
-              <a:t>3</a:t>
+              <a:t>8</a:t>
             </a:fld>
             <a:endParaRPr lang="en-AU" sz="700"/>
           </a:p>
@@ -34392,7 +36023,7 @@
 </p:sld>
 </file>
 
-<file path=ppt/slides/slide4.xml><?xml version="1.0" encoding="utf-8"?>
+<file path=ppt/slides/slide9.xml><?xml version="1.0" encoding="utf-8"?>
 <p:sld xmlns:a="http://schemas.openxmlformats.org/drawingml/2006/main" xmlns:r="http://schemas.openxmlformats.org/officeDocument/2006/relationships" xmlns:p="http://schemas.openxmlformats.org/presentationml/2006/main">
   <p:cSld>
     <p:spTree>
@@ -34515,7 +36146,7 @@
             <a:fld id="{E917DE0E-AFB1-41FD-BC35-27DB61CA125F}" type="slidenum">
               <a:rPr lang="en-AU" smtClean="0"/>
               <a:pPr/>
-              <a:t>4</a:t>
+              <a:t>9</a:t>
             </a:fld>
             <a:endParaRPr lang="en-AU" dirty="0"/>
           </a:p>
@@ -34562,495 +36193,6 @@
     <p:extLst>
       <p:ext uri="{BB962C8B-B14F-4D97-AF65-F5344CB8AC3E}">
         <p14:creationId xmlns:p14="http://schemas.microsoft.com/office/powerpoint/2010/main" val="2699610378"/>
-      </p:ext>
-    </p:extLst>
-  </p:cSld>
-  <p:clrMapOvr>
-    <a:masterClrMapping/>
-  </p:clrMapOvr>
-  <mc:AlternateContent xmlns:mc="http://schemas.openxmlformats.org/markup-compatibility/2006" xmlns:p14="http://schemas.microsoft.com/office/powerpoint/2010/main">
-    <mc:Choice Requires="p14">
-      <p:transition spd="med" p14:dur="700">
-        <p:fade/>
-      </p:transition>
-    </mc:Choice>
-    <mc:Fallback xmlns="">
-      <p:transition spd="med">
-        <p:fade/>
-      </p:transition>
-    </mc:Fallback>
-  </mc:AlternateContent>
-</p:sld>
-</file>
-
-<file path=ppt/slides/slide5.xml><?xml version="1.0" encoding="utf-8"?>
-<p:sld xmlns:a="http://schemas.openxmlformats.org/drawingml/2006/main" xmlns:r="http://schemas.openxmlformats.org/officeDocument/2006/relationships" xmlns:p="http://schemas.openxmlformats.org/presentationml/2006/main">
-  <p:cSld>
-    <p:spTree>
-      <p:nvGrpSpPr>
-        <p:cNvPr id="1" name=""/>
-        <p:cNvGrpSpPr/>
-        <p:nvPr/>
-      </p:nvGrpSpPr>
-      <p:grpSpPr>
-        <a:xfrm>
-          <a:off x="0" y="0"/>
-          <a:ext cx="0" cy="0"/>
-          <a:chOff x="0" y="0"/>
-          <a:chExt cx="0" cy="0"/>
-        </a:xfrm>
-      </p:grpSpPr>
-      <p:sp>
-        <p:nvSpPr>
-          <p:cNvPr id="10" name="Footer Placeholder 1">
-            <a:extLst>
-              <a:ext uri="{FF2B5EF4-FFF2-40B4-BE49-F238E27FC236}">
-                <a16:creationId xmlns:a16="http://schemas.microsoft.com/office/drawing/2014/main" id="{212A69FA-ED78-890A-E3D1-2CEDA8374AAE}"/>
-              </a:ext>
-            </a:extLst>
-          </p:cNvPr>
-          <p:cNvSpPr>
-            <a:spLocks noGrp="1"/>
-          </p:cNvSpPr>
-          <p:nvPr>
-            <p:ph type="ftr" sz="quarter" idx="17"/>
-          </p:nvPr>
-        </p:nvSpPr>
-        <p:spPr>
-          <a:xfrm>
-            <a:off x="695326" y="6526800"/>
-            <a:ext cx="3360109" cy="108000"/>
-          </a:xfrm>
-        </p:spPr>
-        <p:txBody>
-          <a:bodyPr/>
-          <a:lstStyle/>
-          <a:p>
-            <a:endParaRPr lang="en-AU"/>
-          </a:p>
-        </p:txBody>
-      </p:sp>
-      <p:sp>
-        <p:nvSpPr>
-          <p:cNvPr id="5" name="Slide Number Placeholder 4">
-            <a:extLst>
-              <a:ext uri="{FF2B5EF4-FFF2-40B4-BE49-F238E27FC236}">
-                <a16:creationId xmlns:a16="http://schemas.microsoft.com/office/drawing/2014/main" id="{42124E07-F817-8BE4-DDEB-9DB8AE101FDC}"/>
-              </a:ext>
-            </a:extLst>
-          </p:cNvPr>
-          <p:cNvSpPr>
-            <a:spLocks noGrp="1"/>
-          </p:cNvSpPr>
-          <p:nvPr>
-            <p:ph type="sldNum" sz="quarter" idx="18"/>
-          </p:nvPr>
-        </p:nvSpPr>
-        <p:spPr>
-          <a:xfrm>
-            <a:off x="11208568" y="6526800"/>
-            <a:ext cx="288032" cy="108000"/>
-          </a:xfrm>
-        </p:spPr>
-        <p:txBody>
-          <a:bodyPr anchor="ctr">
-            <a:normAutofit/>
-          </a:bodyPr>
-          <a:lstStyle/>
-          <a:p>
-            <a:pPr>
-              <a:spcAft>
-                <a:spcPts val="600"/>
-              </a:spcAft>
-            </a:pPr>
-            <a:fld id="{E917DE0E-AFB1-41FD-BC35-27DB61CA125F}" type="slidenum">
-              <a:rPr lang="en-AU" sz="700" smtClean="0"/>
-              <a:pPr>
-                <a:spcAft>
-                  <a:spcPts val="600"/>
-                </a:spcAft>
-              </a:pPr>
-              <a:t>5</a:t>
-            </a:fld>
-            <a:endParaRPr lang="en-AU" sz="700"/>
-          </a:p>
-        </p:txBody>
-      </p:sp>
-      <p:sp>
-        <p:nvSpPr>
-          <p:cNvPr id="12" name="Content Placeholder 3">
-            <a:extLst>
-              <a:ext uri="{FF2B5EF4-FFF2-40B4-BE49-F238E27FC236}">
-                <a16:creationId xmlns:a16="http://schemas.microsoft.com/office/drawing/2014/main" id="{A7E7BA24-E139-8637-75C3-57E193FCEF37}"/>
-              </a:ext>
-            </a:extLst>
-          </p:cNvPr>
-          <p:cNvSpPr>
-            <a:spLocks noGrp="1"/>
-          </p:cNvSpPr>
-          <p:nvPr>
-            <p:ph sz="quarter" idx="10"/>
-          </p:nvPr>
-        </p:nvSpPr>
-        <p:spPr>
-          <a:xfrm>
-            <a:off x="695326" y="2030400"/>
-            <a:ext cx="5040000" cy="3956400"/>
-          </a:xfrm>
-        </p:spPr>
-        <p:txBody>
-          <a:bodyPr/>
-          <a:lstStyle/>
-          <a:p>
-            <a:pPr marL="285750" indent="-285750">
-              <a:buFont typeface="Arial" panose="020B0604020202020204" pitchFamily="34" charset="0"/>
-              <a:buChar char="•"/>
-            </a:pPr>
-            <a:r>
-              <a:rPr lang="en-US" dirty="0"/>
-              <a:t>Diffusion Bridges Allow us to extend our SDE</a:t>
-            </a:r>
-          </a:p>
-          <a:p>
-            <a:pPr marL="285750" indent="-285750">
-              <a:buFont typeface="Arial" panose="020B0604020202020204" pitchFamily="34" charset="0"/>
-              <a:buChar char="•"/>
-            </a:pPr>
-            <a:r>
-              <a:rPr lang="en-US" dirty="0"/>
-              <a:t>A Diffusion Bridge is an SDE where the value (v) at a time T is known</a:t>
-            </a:r>
-          </a:p>
-          <a:p>
-            <a:pPr marL="285750" indent="-285750">
-              <a:buFont typeface="Arial" panose="020B0604020202020204" pitchFamily="34" charset="0"/>
-              <a:buChar char="•"/>
-            </a:pPr>
-            <a:r>
-              <a:rPr lang="en-US" dirty="0"/>
-              <a:t>Given this there are a set number of solutions to the SDE and we can sample from the list of viable solutions</a:t>
-            </a:r>
-          </a:p>
-          <a:p>
-            <a:pPr marL="285750" indent="-285750">
-              <a:buFont typeface="Arial" panose="020B0604020202020204" pitchFamily="34" charset="0"/>
-              <a:buChar char="•"/>
-            </a:pPr>
-            <a:r>
-              <a:rPr lang="en-US" dirty="0"/>
-              <a:t>For our phylogeny: given two known tip values, we can Simulate BM over the branches between them (T) to our known value (v)</a:t>
-            </a:r>
-          </a:p>
-          <a:p>
-            <a:pPr marL="285750" indent="-285750">
-              <a:buFont typeface="Arial" panose="020B0604020202020204" pitchFamily="34" charset="0"/>
-              <a:buChar char="•"/>
-            </a:pPr>
-            <a:r>
-              <a:rPr lang="en-US" dirty="0"/>
-              <a:t>We can continue this process down the tree leading to our first 2 figures</a:t>
-            </a:r>
-          </a:p>
-        </p:txBody>
-      </p:sp>
-      <p:sp>
-        <p:nvSpPr>
-          <p:cNvPr id="14" name="Title 4">
-            <a:extLst>
-              <a:ext uri="{FF2B5EF4-FFF2-40B4-BE49-F238E27FC236}">
-                <a16:creationId xmlns:a16="http://schemas.microsoft.com/office/drawing/2014/main" id="{F9610EC7-F72E-75B1-F091-08A4F9AAD0C0}"/>
-              </a:ext>
-            </a:extLst>
-          </p:cNvPr>
-          <p:cNvSpPr>
-            <a:spLocks noGrp="1"/>
-          </p:cNvSpPr>
-          <p:nvPr>
-            <p:ph type="title"/>
-          </p:nvPr>
-        </p:nvSpPr>
-        <p:spPr>
-          <a:xfrm>
-            <a:off x="695325" y="763200"/>
-            <a:ext cx="9576000" cy="469056"/>
-          </a:xfrm>
-        </p:spPr>
-        <p:txBody>
-          <a:bodyPr/>
-          <a:lstStyle/>
-          <a:p>
-            <a:r>
-              <a:rPr lang="en-US" dirty="0"/>
-              <a:t>Bridging the Gap</a:t>
-            </a:r>
-          </a:p>
-        </p:txBody>
-      </p:sp>
-      <p:sp>
-        <p:nvSpPr>
-          <p:cNvPr id="16" name="Text Placeholder 5">
-            <a:extLst>
-              <a:ext uri="{FF2B5EF4-FFF2-40B4-BE49-F238E27FC236}">
-                <a16:creationId xmlns:a16="http://schemas.microsoft.com/office/drawing/2014/main" id="{6A13694D-99A6-E16A-C1A6-3D6F0CC30E2A}"/>
-              </a:ext>
-            </a:extLst>
-          </p:cNvPr>
-          <p:cNvSpPr>
-            <a:spLocks noGrp="1"/>
-          </p:cNvSpPr>
-          <p:nvPr>
-            <p:ph type="body" sz="quarter" idx="31"/>
-          </p:nvPr>
-        </p:nvSpPr>
-        <p:spPr>
-          <a:xfrm>
-            <a:off x="695325" y="1364400"/>
-            <a:ext cx="9576000" cy="506132"/>
-          </a:xfrm>
-        </p:spPr>
-        <p:txBody>
-          <a:bodyPr/>
-          <a:lstStyle/>
-          <a:p>
-            <a:r>
-              <a:rPr lang="en-US" dirty="0"/>
-              <a:t>Start with the knowns</a:t>
-            </a:r>
-          </a:p>
-        </p:txBody>
-      </p:sp>
-      <p:pic>
-        <p:nvPicPr>
-          <p:cNvPr id="7" name="Content Placeholder 6" descr="A graph of a tree depth&#10;&#10;Description automatically generated">
-            <a:extLst>
-              <a:ext uri="{FF2B5EF4-FFF2-40B4-BE49-F238E27FC236}">
-                <a16:creationId xmlns:a16="http://schemas.microsoft.com/office/drawing/2014/main" id="{6BAA9862-DD37-1704-41F7-81D4E849A9EE}"/>
-              </a:ext>
-            </a:extLst>
-          </p:cNvPr>
-          <p:cNvPicPr>
-            <a:picLocks noGrp="1" noChangeAspect="1"/>
-          </p:cNvPicPr>
-          <p:nvPr>
-            <p:ph sz="quarter" idx="32"/>
-          </p:nvPr>
-        </p:nvPicPr>
-        <p:blipFill>
-          <a:blip r:embed="rId2"/>
-          <a:stretch>
-            <a:fillRect/>
-          </a:stretch>
-        </p:blipFill>
-        <p:spPr>
-          <a:xfrm>
-            <a:off x="6559888" y="854649"/>
-            <a:ext cx="3527253" cy="2351502"/>
-          </a:xfrm>
-        </p:spPr>
-      </p:pic>
-      <p:pic>
-        <p:nvPicPr>
-          <p:cNvPr id="9" name="Picture 8" descr="A graph of a graph&#10;&#10;Description automatically generated">
-            <a:extLst>
-              <a:ext uri="{FF2B5EF4-FFF2-40B4-BE49-F238E27FC236}">
-                <a16:creationId xmlns:a16="http://schemas.microsoft.com/office/drawing/2014/main" id="{DDE90736-3A54-C926-AD3E-A8A55BA03342}"/>
-              </a:ext>
-            </a:extLst>
-          </p:cNvPr>
-          <p:cNvPicPr>
-            <a:picLocks noChangeAspect="1"/>
-          </p:cNvPicPr>
-          <p:nvPr/>
-        </p:nvPicPr>
-        <p:blipFill>
-          <a:blip r:embed="rId3"/>
-          <a:stretch>
-            <a:fillRect/>
-          </a:stretch>
-        </p:blipFill>
-        <p:spPr>
-          <a:xfrm>
-            <a:off x="6670925" y="3268519"/>
-            <a:ext cx="3600400" cy="2400267"/>
-          </a:xfrm>
-          <a:prstGeom prst="rect">
-            <a:avLst/>
-          </a:prstGeom>
-        </p:spPr>
-      </p:pic>
-      <p:sp>
-        <p:nvSpPr>
-          <p:cNvPr id="11" name="TextBox 10">
-            <a:extLst>
-              <a:ext uri="{FF2B5EF4-FFF2-40B4-BE49-F238E27FC236}">
-                <a16:creationId xmlns:a16="http://schemas.microsoft.com/office/drawing/2014/main" id="{D301F6FD-8306-753C-936F-84B4EE7CA791}"/>
-              </a:ext>
-            </a:extLst>
-          </p:cNvPr>
-          <p:cNvSpPr txBox="1"/>
-          <p:nvPr/>
-        </p:nvSpPr>
-        <p:spPr>
-          <a:xfrm>
-            <a:off x="6816080" y="5638016"/>
-            <a:ext cx="3455246" cy="830997"/>
-          </a:xfrm>
-          <a:prstGeom prst="rect">
-            <a:avLst/>
-          </a:prstGeom>
-          <a:noFill/>
-        </p:spPr>
-        <p:txBody>
-          <a:bodyPr wrap="square" rtlCol="0">
-            <a:spAutoFit/>
-          </a:bodyPr>
-          <a:lstStyle/>
-          <a:p>
-            <a:pPr algn="ctr"/>
-            <a:r>
-              <a:rPr lang="en-US" sz="800" i="1" u="sng" dirty="0"/>
-              <a:t>Figure 4</a:t>
-            </a:r>
-            <a:r>
-              <a:rPr lang="en-US" sz="800" dirty="0"/>
-              <a:t>: Brownian Bridge trait reconstruction between </a:t>
-            </a:r>
-            <a:r>
-              <a:rPr lang="en-US" sz="800" dirty="0" err="1"/>
-              <a:t>Dasyurus</a:t>
-            </a:r>
-            <a:r>
-              <a:rPr lang="en-US" sz="800" dirty="0"/>
-              <a:t> maculatus and </a:t>
-            </a:r>
-            <a:r>
-              <a:rPr lang="en-US" sz="800" dirty="0" err="1"/>
-              <a:t>Dasyurus</a:t>
-            </a:r>
-            <a:r>
-              <a:rPr lang="en-US" sz="800" dirty="0"/>
-              <a:t> </a:t>
-            </a:r>
-            <a:r>
-              <a:rPr lang="en-US" sz="800" dirty="0" err="1"/>
-              <a:t>viverrinus</a:t>
-            </a:r>
-            <a:r>
-              <a:rPr lang="en-US" sz="800" dirty="0"/>
-              <a:t>. </a:t>
-            </a:r>
-            <a:r>
-              <a:rPr lang="en-US" sz="800" b="1" dirty="0"/>
-              <a:t>A) </a:t>
-            </a:r>
-            <a:r>
-              <a:rPr lang="en-US" sz="800" dirty="0"/>
-              <a:t>contributing Brownian Bridges</a:t>
-            </a:r>
-          </a:p>
-          <a:p>
-            <a:pPr algn="ctr"/>
-            <a:r>
-              <a:rPr lang="en-US" sz="800" dirty="0"/>
-              <a:t>to the ancestral trait value of the ancestor, red line indicates the time point of the ancestor </a:t>
-            </a:r>
-            <a:r>
-              <a:rPr lang="en-US" sz="800" b="1" dirty="0"/>
-              <a:t>B) </a:t>
-            </a:r>
-            <a:r>
-              <a:rPr lang="en-US" sz="800" dirty="0"/>
-              <a:t>kernel density estimates of the contributing</a:t>
-            </a:r>
-          </a:p>
-          <a:p>
-            <a:pPr algn="ctr"/>
-            <a:r>
-              <a:rPr lang="en-US" sz="800" dirty="0"/>
-              <a:t>leaves to the resulting ancestral nodes, blue line corresponds to the density seen in figure </a:t>
-            </a:r>
-            <a:r>
-              <a:rPr lang="en-US" sz="800" b="1" dirty="0"/>
-              <a:t>A</a:t>
-            </a:r>
-            <a:endParaRPr lang="en-AU" sz="800" b="1" dirty="0"/>
-          </a:p>
-        </p:txBody>
-      </p:sp>
-      <p:sp>
-        <p:nvSpPr>
-          <p:cNvPr id="13" name="TextBox 12">
-            <a:extLst>
-              <a:ext uri="{FF2B5EF4-FFF2-40B4-BE49-F238E27FC236}">
-                <a16:creationId xmlns:a16="http://schemas.microsoft.com/office/drawing/2014/main" id="{46C4F6BF-44FF-C266-9E16-D0A6E9A6FB4F}"/>
-              </a:ext>
-            </a:extLst>
-          </p:cNvPr>
-          <p:cNvSpPr txBox="1"/>
-          <p:nvPr/>
-        </p:nvSpPr>
-        <p:spPr>
-          <a:xfrm>
-            <a:off x="6343826" y="872949"/>
-            <a:ext cx="432123" cy="369332"/>
-          </a:xfrm>
-          <a:prstGeom prst="rect">
-            <a:avLst/>
-          </a:prstGeom>
-          <a:noFill/>
-        </p:spPr>
-        <p:txBody>
-          <a:bodyPr wrap="square" rtlCol="0">
-            <a:spAutoFit/>
-          </a:bodyPr>
-          <a:lstStyle/>
-          <a:p>
-            <a:r>
-              <a:rPr lang="en-AU" b="1" dirty="0"/>
-              <a:t>A</a:t>
-            </a:r>
-          </a:p>
-        </p:txBody>
-      </p:sp>
-      <p:sp>
-        <p:nvSpPr>
-          <p:cNvPr id="15" name="TextBox 14">
-            <a:extLst>
-              <a:ext uri="{FF2B5EF4-FFF2-40B4-BE49-F238E27FC236}">
-                <a16:creationId xmlns:a16="http://schemas.microsoft.com/office/drawing/2014/main" id="{60E80DBE-9086-39D4-2676-68F92E9ACA6D}"/>
-              </a:ext>
-            </a:extLst>
-          </p:cNvPr>
-          <p:cNvSpPr txBox="1"/>
-          <p:nvPr/>
-        </p:nvSpPr>
-        <p:spPr>
-          <a:xfrm>
-            <a:off x="6434089" y="3409848"/>
-            <a:ext cx="432123" cy="369332"/>
-          </a:xfrm>
-          <a:prstGeom prst="rect">
-            <a:avLst/>
-          </a:prstGeom>
-          <a:noFill/>
-        </p:spPr>
-        <p:txBody>
-          <a:bodyPr wrap="square" rtlCol="0">
-            <a:spAutoFit/>
-          </a:bodyPr>
-          <a:lstStyle/>
-          <a:p>
-            <a:r>
-              <a:rPr lang="en-AU" b="1" dirty="0"/>
-              <a:t>B</a:t>
-            </a:r>
-          </a:p>
-        </p:txBody>
-      </p:sp>
-    </p:spTree>
-    <p:extLst>
-      <p:ext uri="{BB962C8B-B14F-4D97-AF65-F5344CB8AC3E}">
-        <p14:creationId xmlns:p14="http://schemas.microsoft.com/office/powerpoint/2010/main" val="797725360"/>
       </p:ext>
     </p:extLst>
   </p:cSld>

</xml_diff>